<commit_message>
docs: slides link to the live demo (QR code) and GitHub repo
Co-Authored-By: Claude Opus 5.5 <noreply@anthropic.com>
</commit_message>
<xml_diff>
--- a/RAG_Autopsy_HYPNEXIS26.pptx
+++ b/RAG_Autopsy_HYPNEXIS26.pptx
@@ -1023,7 +1023,7 @@
           <a:lstStyle/>
           <a:p>
             <a:r>
-              <a:t>Thank you. Happy to show the live demo or take questions.</a:t>
+              <a:t>Thank you. The live demo is at rag-autopsy.vercel.app (scan the QR code), and the code is on GitHub. Happy to take questions.</a:t>
             </a:r>
           </a:p>
         </p:txBody>
@@ -5976,16 +5976,61 @@
           </a:prstGeom>
         </p:spPr>
       </p:pic>
+      <p:sp>
+        <p:nvSpPr>
+          <p:cNvPr id="27" name="Live demo link"/>
+          <p:cNvSpPr txBox="1"/>
+          <p:nvPr/>
+        </p:nvSpPr>
+        <p:spPr>
+          <a:xfrm>
+            <a:off x="731520" y="4370832"/>
+            <a:ext cx="3108960" cy="365760"/>
+          </a:xfrm>
+          <a:prstGeom prst="rect">
+            <a:avLst/>
+          </a:prstGeom>
+          <a:noFill/>
+        </p:spPr>
+        <p:txBody>
+          <a:bodyPr wrap="square" lIns="0" rIns="0" tIns="0" bIns="0" anchor="t">
+            <a:spAutoFit/>
+          </a:bodyPr>
+          <a:lstStyle/>
+          <a:p>
+            <a:pPr algn="l"/>
+            <a:r>
+              <a:rPr sz="1250" b="1" i="0">
+                <a:solidFill>
+                  <a:srgbClr val="4DA3FF"/>
+                </a:solidFill>
+                <a:latin typeface="Calibri"/>
+              </a:rPr>
+              <a:t>▶  Try it live: </a:t>
+            </a:r>
+            <a:r>
+              <a:rPr sz="1250" b="1" i="0">
+                <a:solidFill>
+                  <a:srgbClr val="FFFFFF"/>
+                </a:solidFill>
+                <a:latin typeface="Calibri"/>
+                <a:hlinkClick r:id="rId4"/>
+              </a:rPr>
+              <a:t>rag-autopsy.vercel.app</a:t>
+            </a:r>
+          </a:p>
+        </p:txBody>
+      </p:sp>
       <p:pic>
         <p:nvPicPr>
-          <p:cNvPr id="27" name="Picture 26" descr="dash_autopsy.png"/>
+          <p:cNvPr id="28" name="Picture 27" descr="dash_autopsy.png"/>
           <p:cNvPicPr>
             <a:picLocks noChangeAspect="1"/>
           </p:cNvPicPr>
           <p:nvPr/>
         </p:nvPicPr>
         <p:blipFill>
-          <a:blip r:embed="rId4"/>
+          <a:blip r:embed="rId5"/>
           <a:stretch>
             <a:fillRect/>
           </a:stretch>
@@ -9041,6 +9086,250 @@
               <a:t>CREATE / AN / IMPACT</a:t>
             </a:r>
             <a:endParaRPr lang="en-US" sz="1300" dirty="0"/>
+          </a:p>
+        </p:txBody>
+      </p:sp>
+      <p:sp>
+        <p:nvSpPr>
+          <p:cNvPr id="6" name="Links"/>
+          <p:cNvSpPr txBox="1"/>
+          <p:nvPr/>
+        </p:nvSpPr>
+        <p:spPr>
+          <a:xfrm>
+            <a:off x="548640" y="5532120"/>
+            <a:ext cx="7315200" cy="320040"/>
+          </a:xfrm>
+          <a:prstGeom prst="rect">
+            <a:avLst/>
+          </a:prstGeom>
+          <a:noFill/>
+        </p:spPr>
+        <p:txBody>
+          <a:bodyPr wrap="square" lIns="0" rIns="0" tIns="0" bIns="0" anchor="t">
+            <a:spAutoFit/>
+          </a:bodyPr>
+          <a:lstStyle/>
+          <a:p>
+            <a:pPr algn="l"/>
+            <a:r>
+              <a:rPr sz="1300" b="1" i="0">
+                <a:solidFill>
+                  <a:srgbClr val="4DA3FF"/>
+                </a:solidFill>
+                <a:latin typeface="Calibri"/>
+              </a:rPr>
+              <a:t>Live demo  </a:t>
+            </a:r>
+            <a:r>
+              <a:rPr sz="1300" b="0" i="0">
+                <a:solidFill>
+                  <a:srgbClr val="FFFFFF"/>
+                </a:solidFill>
+                <a:latin typeface="Calibri"/>
+                <a:hlinkClick r:id="rId4"/>
+              </a:rPr>
+              <a:t>rag-autopsy.vercel.app</a:t>
+            </a:r>
+            <a:r>
+              <a:rPr sz="1300" b="1" i="0">
+                <a:solidFill>
+                  <a:srgbClr val="4DA3FF"/>
+                </a:solidFill>
+                <a:latin typeface="Calibri"/>
+              </a:rPr>
+              <a:t>      Code  </a:t>
+            </a:r>
+            <a:r>
+              <a:rPr sz="1300" b="0" i="0">
+                <a:solidFill>
+                  <a:srgbClr val="FFFFFF"/>
+                </a:solidFill>
+                <a:latin typeface="Calibri"/>
+                <a:hlinkClick r:id="rId5"/>
+              </a:rPr>
+              <a:t>github.com/GargeeTripathi/rag-autopsy</a:t>
+            </a:r>
+          </a:p>
+        </p:txBody>
+      </p:sp>
+      <p:sp>
+        <p:nvSpPr>
+          <p:cNvPr id="7" name="QR card"/>
+          <p:cNvSpPr/>
+          <p:nvPr/>
+        </p:nvSpPr>
+        <p:spPr>
+          <a:xfrm>
+            <a:off x="8732520" y="1600200"/>
+            <a:ext cx="2926080" cy="3794760"/>
+          </a:xfrm>
+          <a:prstGeom prst="roundRect">
+            <a:avLst>
+              <a:gd name="adj" fmla="val 8000"/>
+            </a:avLst>
+          </a:prstGeom>
+          <a:solidFill>
+            <a:srgbClr val="0B1A4A">
+              <a:alpha val="80000"/>
+            </a:srgbClr>
+          </a:solidFill>
+          <a:ln w="12700">
+            <a:solidFill>
+              <a:srgbClr val="1E5BFF"/>
+            </a:solidFill>
+          </a:ln>
+          <a:effectLst/>
+        </p:spPr>
+        <p:style>
+          <a:lnRef idx="1">
+            <a:schemeClr val="accent1"/>
+          </a:lnRef>
+          <a:fillRef idx="3">
+            <a:schemeClr val="accent1"/>
+          </a:fillRef>
+          <a:effectRef idx="2">
+            <a:schemeClr val="accent1"/>
+          </a:effectRef>
+          <a:fontRef idx="minor">
+            <a:schemeClr val="lt1"/>
+          </a:fontRef>
+        </p:style>
+        <p:txBody>
+          <a:bodyPr rtlCol="0" anchor="ctr"/>
+          <a:lstStyle/>
+          <a:p/>
+        </p:txBody>
+      </p:sp>
+      <p:pic>
+        <p:nvPicPr>
+          <p:cNvPr id="8" name="Live demo QR code" descr="qr_demo.png">
+            <a:hlinkClick r:id="rId4"/>
+          </p:cNvPr>
+          <p:cNvPicPr>
+            <a:picLocks noChangeAspect="1"/>
+          </p:cNvPicPr>
+          <p:nvPr/>
+        </p:nvPicPr>
+        <p:blipFill>
+          <a:blip r:embed="rId6"/>
+          <a:stretch>
+            <a:fillRect/>
+          </a:stretch>
+        </p:blipFill>
+        <p:spPr>
+          <a:xfrm>
+            <a:off x="9098280" y="1874519"/>
+            <a:ext cx="2194560" cy="2194560"/>
+          </a:xfrm>
+          <a:prstGeom prst="rect">
+            <a:avLst/>
+          </a:prstGeom>
+        </p:spPr>
+      </p:pic>
+      <p:sp>
+        <p:nvSpPr>
+          <p:cNvPr id="9" name="TextBox 8"/>
+          <p:cNvSpPr txBox="1"/>
+          <p:nvPr/>
+        </p:nvSpPr>
+        <p:spPr>
+          <a:xfrm>
+            <a:off x="8869680" y="4206240"/>
+            <a:ext cx="2651760" cy="320040"/>
+          </a:xfrm>
+          <a:prstGeom prst="rect">
+            <a:avLst/>
+          </a:prstGeom>
+          <a:noFill/>
+        </p:spPr>
+        <p:txBody>
+          <a:bodyPr wrap="square" lIns="0" rIns="0" tIns="0" bIns="0" anchor="t">
+            <a:spAutoFit/>
+          </a:bodyPr>
+          <a:lstStyle/>
+          <a:p>
+            <a:pPr algn="ctr"/>
+            <a:r>
+              <a:rPr sz="1100" b="1" i="0">
+                <a:solidFill>
+                  <a:srgbClr val="4DA3FF"/>
+                </a:solidFill>
+                <a:latin typeface="Arial"/>
+              </a:rPr>
+              <a:t>SCAN FOR THE LIVE DEMO</a:t>
+            </a:r>
+          </a:p>
+        </p:txBody>
+      </p:sp>
+      <p:sp>
+        <p:nvSpPr>
+          <p:cNvPr id="10" name="TextBox 9"/>
+          <p:cNvSpPr txBox="1"/>
+          <p:nvPr/>
+        </p:nvSpPr>
+        <p:spPr>
+          <a:xfrm>
+            <a:off x="8869680" y="4553712"/>
+            <a:ext cx="2651760" cy="320040"/>
+          </a:xfrm>
+          <a:prstGeom prst="rect">
+            <a:avLst/>
+          </a:prstGeom>
+          <a:noFill/>
+        </p:spPr>
+        <p:txBody>
+          <a:bodyPr wrap="square" lIns="0" rIns="0" tIns="0" bIns="0" anchor="t">
+            <a:spAutoFit/>
+          </a:bodyPr>
+          <a:lstStyle/>
+          <a:p>
+            <a:pPr algn="ctr"/>
+            <a:r>
+              <a:rPr sz="1300" b="0" i="0">
+                <a:solidFill>
+                  <a:srgbClr val="FFFFFF"/>
+                </a:solidFill>
+                <a:latin typeface="Calibri"/>
+                <a:hlinkClick r:id="rId4"/>
+              </a:rPr>
+              <a:t>rag-autopsy.vercel.app</a:t>
+            </a:r>
+          </a:p>
+        </p:txBody>
+      </p:sp>
+      <p:sp>
+        <p:nvSpPr>
+          <p:cNvPr id="11" name="TextBox 10"/>
+          <p:cNvSpPr txBox="1"/>
+          <p:nvPr/>
+        </p:nvSpPr>
+        <p:spPr>
+          <a:xfrm>
+            <a:off x="8869680" y="4873752"/>
+            <a:ext cx="2651760" cy="365760"/>
+          </a:xfrm>
+          <a:prstGeom prst="rect">
+            <a:avLst/>
+          </a:prstGeom>
+          <a:noFill/>
+        </p:spPr>
+        <p:txBody>
+          <a:bodyPr wrap="square" lIns="0" rIns="0" tIns="0" bIns="0" anchor="t">
+            <a:spAutoFit/>
+          </a:bodyPr>
+          <a:lstStyle/>
+          <a:p>
+            <a:pPr algn="ctr"/>
+            <a:r>
+              <a:rPr sz="1100" b="0" i="0">
+                <a:solidFill>
+                  <a:srgbClr val="9CC4FF"/>
+                </a:solidFill>
+                <a:latin typeface="Calibri"/>
+              </a:rPr>
+              <a:t>Explore all 83 question autopsies</a:t>
+            </a:r>
           </a:p>
         </p:txBody>
       </p:sp>

</xml_diff>

<commit_message>
docs: slides cover live document upload and deployment
Co-Authored-By: Claude Opus 5.5 <noreply@anthropic.com>
</commit_message>
<xml_diff>
--- a/RAG_Autopsy_HYPNEXIS26.pptx
+++ b/RAG_Autopsy_HYPNEXIS26.pptx
@@ -593,7 +593,7 @@
           <a:lstStyle/>
           <a:p>
             <a:r>
-              <a:t>One screen. The top row is the health of the RAG with confidence intervals. Pick a failure on the left and you get its autopsy: the answer coloured sentence by sentence, the ranked chunks with the gold one outlined, every lens's vote, and the counterfactual proof. The flow is three steps: documents in, evaluation run, apply the fix.</a:t>
+              <a:t>Users upload their own documents right on the live site, or try the demo corpus. One screen. The top row is the health of the RAG with confidence intervals. Pick a failure on the left and you get its autopsy: the answer coloured sentence by sentence, the ranked chunks with the gold one outlined, every lens's vote, and the counterfactual proof. The flow is three steps: documents in, evaluation run, apply the fix.</a:t>
             </a:r>
           </a:p>
         </p:txBody>
@@ -679,7 +679,7 @@
           <a:lstStyle/>
           <a:p>
             <a:r>
-              <a:t>It already works end to end on a CPU laptop with free-tier APIs. The cascade keeps cost low: 0.36 LLM calls per question, and caching makes re-runs free. Main risks are rate limits, judge bias and imperfect generated questions, and each has a mitigation built in.</a:t>
+              <a:t>It is deployed: the dashboard runs on Vercel and visitors can upload their own documents, which go through a secure tunnel to our backend, with limits that protect the API quota. It already works end to end on a CPU laptop with free-tier APIs. The cascade keeps cost low: 0.36 LLM calls per question, and caching makes re-runs free. Main risks are rate limits, judge bias and imperfect generated questions, and each has a mitigation built in.</a:t>
             </a:r>
           </a:p>
         </p:txBody>
@@ -5307,7 +5307,7 @@
                 <a:ea typeface="Calibri" pitchFamily="34" charset="-122"/>
                 <a:cs typeface="Calibri" pitchFamily="34" charset="-120"/>
               </a:rPr>
-              <a:t>Overview: </a:t>
+              <a:t>Upload: </a:t>
             </a:r>
             <a:r>
               <a:rPr lang="en-US" sz="1250" dirty="0">
@@ -5318,7 +5318,7 @@
                 <a:ea typeface="Calibri" pitchFamily="34" charset="-122"/>
                 <a:cs typeface="Calibri" pitchFamily="34" charset="-120"/>
               </a:rPr>
-              <a:t>4 scorecards with 95% CIs, root-cause mix, LLM cost</a:t>
+              <a:t>PDF, Word, Markdown or text, right on the live site</a:t>
             </a:r>
             <a:endParaRPr lang="en-US" sz="1400" dirty="0"/>
           </a:p>
@@ -5339,7 +5339,7 @@
                 <a:ea typeface="Calibri" pitchFamily="34" charset="-122"/>
                 <a:cs typeface="Calibri" pitchFamily="34" charset="-120"/>
               </a:rPr>
-              <a:t>Autopsy: </a:t>
+              <a:t>Overview: </a:t>
             </a:r>
             <a:r>
               <a:rPr lang="en-US" sz="1250" dirty="0">
@@ -5350,7 +5350,7 @@
                 <a:ea typeface="Calibri" pitchFamily="34" charset="-122"/>
                 <a:cs typeface="Calibri" pitchFamily="34" charset="-120"/>
               </a:rPr>
-              <a:t>answer sentences green / red, ranked chunks with gold outlined</a:t>
+              <a:t>4 scorecards with 95% CIs, root-cause mix, LLM cost</a:t>
             </a:r>
             <a:endParaRPr lang="en-US" sz="1400" dirty="0"/>
           </a:p>
@@ -5371,7 +5371,7 @@
                 <a:ea typeface="Calibri" pitchFamily="34" charset="-122"/>
                 <a:cs typeface="Calibri" pitchFamily="34" charset="-120"/>
               </a:rPr>
-              <a:t>Tabs: </a:t>
+              <a:t>Autopsy: </a:t>
             </a:r>
             <a:r>
               <a:rPr lang="en-US" sz="1250" dirty="0">
@@ -5382,7 +5382,7 @@
                 <a:ea typeface="Calibri" pitchFamily="34" charset="-122"/>
                 <a:cs typeface="Calibri" pitchFamily="34" charset="-120"/>
               </a:rPr>
-              <a:t>evidence · lens votes · counterfactual proof</a:t>
+              <a:t>answer sentences green / red, ranked chunks with gold outlined</a:t>
             </a:r>
             <a:endParaRPr lang="en-US" sz="1400" dirty="0"/>
           </a:p>
@@ -5403,7 +5403,7 @@
                 <a:ea typeface="Calibri" pitchFamily="34" charset="-122"/>
                 <a:cs typeface="Calibri" pitchFamily="34" charset="-120"/>
               </a:rPr>
-              <a:t>Colour-coded causes, </a:t>
+              <a:t>Tabs: </a:t>
             </a:r>
             <a:r>
               <a:rPr lang="en-US" sz="1250" dirty="0">
@@ -5414,7 +5414,7 @@
                 <a:ea typeface="Calibri" pitchFamily="34" charset="-122"/>
                 <a:cs typeface="Calibri" pitchFamily="34" charset="-120"/>
               </a:rPr>
-              <a:t>dark &amp; light themes</a:t>
+              <a:t>evidence · lens votes · counterfactual proof</a:t>
             </a:r>
             <a:endParaRPr lang="en-US" sz="1400" dirty="0"/>
           </a:p>
@@ -5585,7 +5585,7 @@
                 <a:ea typeface="Calibri" pitchFamily="34" charset="-122"/>
                 <a:cs typeface="Calibri" pitchFamily="34" charset="-120"/>
               </a:rPr>
-              <a:t>Load your documents or try the demo corpus</a:t>
+              <a:t>Upload your documents (PDF, Word, MD) or try the demo</a:t>
             </a:r>
             <a:endParaRPr lang="en-US" sz="1400" dirty="0"/>
           </a:p>
@@ -6006,7 +6006,7 @@
                 </a:solidFill>
                 <a:latin typeface="Calibri"/>
               </a:rPr>
-              <a:t>▶  Try it live: </a:t>
+              <a:t>▶  Upload live: </a:t>
             </a:r>
             <a:r>
               <a:rPr sz="1250" b="1" i="0">
@@ -6689,7 +6689,7 @@
                 <a:ea typeface="Calibri" pitchFamily="34" charset="-122"/>
                 <a:cs typeface="Calibri" pitchFamily="34" charset="-120"/>
               </a:rPr>
-              <a:t>Self-hosted: </a:t>
+              <a:t>Deployed: </a:t>
             </a:r>
             <a:r>
               <a:rPr lang="en-US" sz="1300" dirty="0">
@@ -6700,7 +6700,39 @@
                 <a:ea typeface="Calibri" pitchFamily="34" charset="-122"/>
                 <a:cs typeface="Calibri" pitchFamily="34" charset="-120"/>
               </a:rPr>
-              <a:t>documents stay local; only prompts reach the LLM API</a:t>
+              <a:t>dashboard on Vercel; backend via a secure Cloudflare tunnel; uploads capped at 3 files / 2 MB</a:t>
+            </a:r>
+            <a:endParaRPr lang="en-US" sz="1400" dirty="0"/>
+          </a:p>
+          <a:p>
+            <a:pPr marL="342900" indent="-342900">
+              <a:spcAft>
+                <a:spcPts val="600"/>
+              </a:spcAft>
+              <a:buSzPct val="100000"/>
+              <a:buChar char="•"/>
+            </a:pPr>
+            <a:r>
+              <a:rPr lang="en-US" sz="1300" dirty="0" b="1">
+                <a:solidFill>
+                  <a:srgbClr val="FFFFFF"/>
+                </a:solidFill>
+                <a:latin typeface="Calibri" pitchFamily="34" charset="0"/>
+                <a:ea typeface="Calibri" pitchFamily="34" charset="-122"/>
+                <a:cs typeface="Calibri" pitchFamily="34" charset="-120"/>
+              </a:rPr>
+              <a:t>Data stays with the team's backend; </a:t>
+            </a:r>
+            <a:r>
+              <a:rPr lang="en-US" sz="1300" dirty="0">
+                <a:solidFill>
+                  <a:srgbClr val="FFFFFF"/>
+                </a:solidFill>
+                <a:latin typeface="Calibri" pitchFamily="34" charset="0"/>
+                <a:ea typeface="Calibri" pitchFamily="34" charset="-122"/>
+                <a:cs typeface="Calibri" pitchFamily="34" charset="-120"/>
+              </a:rPr>
+              <a:t>only prompts reach the LLM API</a:t>
             </a:r>
             <a:endParaRPr lang="en-US" sz="1400" dirty="0"/>
           </a:p>
@@ -9328,7 +9360,7 @@
                 </a:solidFill>
                 <a:latin typeface="Calibri"/>
               </a:rPr>
-              <a:t>Explore all 83 question autopsies</a:t>
+              <a:t>Explore the demo or upload your own docs</a:t>
             </a:r>
           </a:p>
         </p:txBody>

</xml_diff>

<commit_message>
docs: slides show the new upload screen; format-tolerant parsing; 25 tests
Co-Authored-By: Claude Opus 5.5 <noreply@anthropic.com>
</commit_message>
<xml_diff>
--- a/RAG_Autopsy_HYPNEXIS26.pptx
+++ b/RAG_Autopsy_HYPNEXIS26.pptx
@@ -593,7 +593,7 @@
           <a:lstStyle/>
           <a:p>
             <a:r>
-              <a:t>Users upload their own documents right on the live site, or try the demo corpus. One screen. The top row is the health of the RAG with confidence intervals. Pick a failure on the left and you get its autopsy: the answer coloured sentence by sentence, the ranked chunks with the gold one outlined, every lens's vote, and the counterfactual proof. The flow is three steps: documents in, evaluation run, apply the fix.</a:t>
+              <a:t>Users upload their own documents right on the live site, or try the demo corpus. The upload step confirms each file and shows live progress while questions are written. One screen. The top row is the health of the RAG with confidence intervals. Pick a failure on the left and you get its autopsy: the answer coloured sentence by sentence, the ranked chunks with the gold one outlined, every lens's vote, and the counterfactual proof. The flow is three steps: documents in, evaluation run, apply the fix.</a:t>
             </a:r>
           </a:p>
         </p:txBody>
@@ -5318,7 +5318,7 @@
                 <a:ea typeface="Calibri" pitchFamily="34" charset="-122"/>
                 <a:cs typeface="Calibri" pitchFamily="34" charset="-120"/>
               </a:rPr>
-              <a:t>PDF, Word, Markdown or text, right on the live site</a:t>
+              <a:t>PDF, Word, Markdown or text on the live site, with progress and file confirmation</a:t>
             </a:r>
             <a:endParaRPr lang="en-US" sz="1400" dirty="0"/>
           </a:p>
@@ -5954,7 +5954,7 @@
       </p:sp>
       <p:pic>
         <p:nvPicPr>
-          <p:cNvPr id="26" name="Picture 25" descr="dash_overview.png"/>
+          <p:cNvPr id="26" name="Picture 25" descr="dash_upload.png"/>
           <p:cNvPicPr>
             <a:picLocks noChangeAspect="1"/>
           </p:cNvPicPr>
@@ -5968,8 +5968,8 @@
         </p:blipFill>
         <p:spPr>
           <a:xfrm>
-            <a:off x="731520" y="4892040"/>
-            <a:ext cx="3108960" cy="1014730"/>
+            <a:off x="731520" y="4846320"/>
+            <a:ext cx="3108960" cy="1001191"/>
           </a:xfrm>
           <a:prstGeom prst="rect">
             <a:avLst/>
@@ -6349,7 +6349,7 @@
                 <a:ea typeface="Calibri" pitchFamily="34" charset="-122"/>
                 <a:cs typeface="Calibri" pitchFamily="34" charset="-120"/>
               </a:rPr>
-              <a:t>24 unit tests, </a:t>
+              <a:t>25 unit tests, </a:t>
             </a:r>
             <a:r>
               <a:rPr lang="en-US" sz="1300" dirty="0">
@@ -6796,7 +6796,7 @@
                 <a:ea typeface="Calibri" pitchFamily="34" charset="-122"/>
                 <a:cs typeface="Calibri" pitchFamily="34" charset="-120"/>
               </a:rPr>
-              <a:t>rate-limit-aware retries + cache; judge from a different model family; evidence-verified questions + human-review flags</a:t>
+              <a:t>rate-limit-aware retries + cache; format-tolerant parsing of model output; judge from a different model family; evidence-verified questions + human-review flags</a:t>
             </a:r>
             <a:endParaRPr lang="en-US" sz="1400" dirty="0"/>
           </a:p>

</xml_diff>

<commit_message>
Deck: add GitHub repo QR card to closing slide
Co-Authored-By: Claude Opus 5.5 <noreply@anthropic.com>
</commit_message>
<xml_diff>
--- a/RAG_Autopsy_HYPNEXIS26.pptx
+++ b/RAG_Autopsy_HYPNEXIS26.pptx
@@ -1023,7 +1023,7 @@
           <a:lstStyle/>
           <a:p>
             <a:r>
-              <a:t>Thank you. The live demo is at rag-autopsy.vercel.app (scan the QR code), and the code is on GitHub. Happy to take questions.</a:t>
+              <a:t>Thank you. The live demo is at rag-autopsy.vercel.app (scan the QR code), and the code, with a full README and architecture diagram, is on GitHub at github.com/GargeeTripathi/rag-autopsy (second QR code). Happy to take questions.</a:t>
             </a:r>
           </a:p>
         </p:txBody>
@@ -9361,6 +9361,186 @@
                 <a:latin typeface="Calibri"/>
               </a:rPr>
               <a:t>Explore the demo or upload your own docs</a:t>
+            </a:r>
+          </a:p>
+        </p:txBody>
+      </p:sp>
+      <p:sp>
+        <p:nvSpPr>
+          <p:cNvPr id="12" name="Repo QR card"/>
+          <p:cNvSpPr/>
+          <p:nvPr/>
+        </p:nvSpPr>
+        <p:spPr>
+          <a:xfrm>
+            <a:off x="5623560" y="1600200"/>
+            <a:ext cx="2926080" cy="3794760"/>
+          </a:xfrm>
+          <a:prstGeom prst="roundRect">
+            <a:avLst>
+              <a:gd name="adj" fmla="val 8000"/>
+            </a:avLst>
+          </a:prstGeom>
+          <a:solidFill>
+            <a:srgbClr val="0B1A4A">
+              <a:alpha val="80000"/>
+            </a:srgbClr>
+          </a:solidFill>
+          <a:ln w="12700">
+            <a:solidFill>
+              <a:srgbClr val="1E5BFF"/>
+            </a:solidFill>
+          </a:ln>
+          <a:effectLst/>
+        </p:spPr>
+        <p:style>
+          <a:lnRef idx="1">
+            <a:schemeClr val="accent1"/>
+          </a:lnRef>
+          <a:fillRef idx="3">
+            <a:schemeClr val="accent1"/>
+          </a:fillRef>
+          <a:effectRef idx="2">
+            <a:schemeClr val="accent1"/>
+          </a:effectRef>
+          <a:fontRef idx="minor">
+            <a:schemeClr val="lt1"/>
+          </a:fontRef>
+        </p:style>
+        <p:txBody>
+          <a:bodyPr rtlCol="0" anchor="ctr"/>
+          <a:lstStyle/>
+          <a:p/>
+        </p:txBody>
+      </p:sp>
+      <p:pic>
+        <p:nvPicPr>
+          <p:cNvPr id="13" name="GitHub repo QR code" descr="qr_repo.png">
+            <a:hlinkClick r:id="rId5"/>
+          </p:cNvPr>
+          <p:cNvPicPr>
+            <a:picLocks noChangeAspect="1"/>
+          </p:cNvPicPr>
+          <p:nvPr/>
+        </p:nvPicPr>
+        <p:blipFill>
+          <a:blip r:embed="rId7"/>
+          <a:stretch>
+            <a:fillRect/>
+          </a:stretch>
+        </p:blipFill>
+        <p:spPr>
+          <a:xfrm>
+            <a:off x="5989320" y="1874519"/>
+            <a:ext cx="2194560" cy="2194560"/>
+          </a:xfrm>
+          <a:prstGeom prst="rect">
+            <a:avLst/>
+          </a:prstGeom>
+        </p:spPr>
+      </p:pic>
+      <p:sp>
+        <p:nvSpPr>
+          <p:cNvPr id="14" name="TextBox 13"/>
+          <p:cNvSpPr txBox="1"/>
+          <p:nvPr/>
+        </p:nvSpPr>
+        <p:spPr>
+          <a:xfrm>
+            <a:off x="5760720" y="4206240"/>
+            <a:ext cx="2651760" cy="320040"/>
+          </a:xfrm>
+          <a:prstGeom prst="rect">
+            <a:avLst/>
+          </a:prstGeom>
+          <a:noFill/>
+        </p:spPr>
+        <p:txBody>
+          <a:bodyPr wrap="square" lIns="0" rIns="0" tIns="0" bIns="0" anchor="t">
+            <a:spAutoFit/>
+          </a:bodyPr>
+          <a:lstStyle/>
+          <a:p>
+            <a:pPr algn="ctr"/>
+            <a:r>
+              <a:rPr sz="1100" b="1" i="0">
+                <a:solidFill>
+                  <a:srgbClr val="4DA3FF"/>
+                </a:solidFill>
+                <a:latin typeface="Arial"/>
+              </a:rPr>
+              <a:t>SCAN FOR THE SOURCE CODE</a:t>
+            </a:r>
+          </a:p>
+        </p:txBody>
+      </p:sp>
+      <p:sp>
+        <p:nvSpPr>
+          <p:cNvPr id="15" name="TextBox 14"/>
+          <p:cNvSpPr txBox="1"/>
+          <p:nvPr/>
+        </p:nvSpPr>
+        <p:spPr>
+          <a:xfrm>
+            <a:off x="5760720" y="4553712"/>
+            <a:ext cx="2651760" cy="320040"/>
+          </a:xfrm>
+          <a:prstGeom prst="rect">
+            <a:avLst/>
+          </a:prstGeom>
+          <a:noFill/>
+        </p:spPr>
+        <p:txBody>
+          <a:bodyPr wrap="square" lIns="0" rIns="0" tIns="0" bIns="0" anchor="t">
+            <a:spAutoFit/>
+          </a:bodyPr>
+          <a:lstStyle/>
+          <a:p>
+            <a:pPr algn="ctr"/>
+            <a:r>
+              <a:rPr sz="1300" b="0" i="0">
+                <a:solidFill>
+                  <a:srgbClr val="FFFFFF"/>
+                </a:solidFill>
+                <a:latin typeface="Calibri"/>
+                <a:hlinkClick r:id="rId5"/>
+              </a:rPr>
+              <a:t>GitHub repo</a:t>
+            </a:r>
+          </a:p>
+        </p:txBody>
+      </p:sp>
+      <p:sp>
+        <p:nvSpPr>
+          <p:cNvPr id="16" name="TextBox 15"/>
+          <p:cNvSpPr txBox="1"/>
+          <p:nvPr/>
+        </p:nvSpPr>
+        <p:spPr>
+          <a:xfrm>
+            <a:off x="5760720" y="4873752"/>
+            <a:ext cx="2651760" cy="365760"/>
+          </a:xfrm>
+          <a:prstGeom prst="rect">
+            <a:avLst/>
+          </a:prstGeom>
+          <a:noFill/>
+        </p:spPr>
+        <p:txBody>
+          <a:bodyPr wrap="square" lIns="0" rIns="0" tIns="0" bIns="0" anchor="t">
+            <a:spAutoFit/>
+          </a:bodyPr>
+          <a:lstStyle/>
+          <a:p>
+            <a:pPr algn="ctr"/>
+            <a:r>
+              <a:rPr sz="1100" b="0" i="0">
+                <a:solidFill>
+                  <a:srgbClr val="9CC4FF"/>
+                </a:solidFill>
+                <a:latin typeface="Calibri"/>
+              </a:rPr>
+              <a:t>README, architecture diagram and setup</a:t>
             </a:r>
           </a:p>
         </p:txBody>

</xml_diff>

<commit_message>
Deck: live demo link and demo-mode note on cover slide
Co-Authored-By: Claude Opus 5.5 <noreply@anthropic.com>
</commit_message>
<xml_diff>
--- a/RAG_Autopsy_HYPNEXIS26.pptx
+++ b/RAG_Autopsy_HYPNEXIS26.pptx
@@ -2470,6 +2470,143 @@
               <a:t>hypnexismuj.com   |   @hypnexis.muj   |   hypnexis2026@muj.manipal.edu</a:t>
             </a:r>
             <a:endParaRPr lang="en-US" sz="1100" dirty="0"/>
+          </a:p>
+        </p:txBody>
+      </p:sp>
+      <p:sp>
+        <p:nvSpPr>
+          <p:cNvPr id="21" name="Cover demo link"/>
+          <p:cNvSpPr txBox="1"/>
+          <p:nvPr/>
+        </p:nvSpPr>
+        <p:spPr>
+          <a:xfrm>
+            <a:off x="548640" y="5230368"/>
+            <a:ext cx="6400800" cy="320040"/>
+          </a:xfrm>
+          <a:prstGeom prst="rect">
+            <a:avLst/>
+          </a:prstGeom>
+          <a:noFill/>
+        </p:spPr>
+        <p:txBody>
+          <a:bodyPr wrap="square" lIns="0" rIns="0" tIns="0" bIns="0" anchor="t">
+            <a:spAutoFit/>
+          </a:bodyPr>
+          <a:lstStyle/>
+          <a:p>
+            <a:pPr algn="l"/>
+            <a:r>
+              <a:rPr sz="1400" b="1" i="0">
+                <a:solidFill>
+                  <a:srgbClr val="4DA3FF"/>
+                </a:solidFill>
+                <a:latin typeface="Calibri"/>
+              </a:rPr>
+              <a:t>▶  Live demo: </a:t>
+            </a:r>
+            <a:r>
+              <a:rPr sz="1400" b="1" i="0">
+                <a:solidFill>
+                  <a:srgbClr val="FFFFFF"/>
+                </a:solidFill>
+                <a:latin typeface="Calibri"/>
+                <a:hlinkClick r:id="rId4"/>
+              </a:rPr>
+              <a:t>rag-autopsy.vercel.app</a:t>
+            </a:r>
+          </a:p>
+        </p:txBody>
+      </p:sp>
+      <p:sp>
+        <p:nvSpPr>
+          <p:cNvPr id="22" name="Demo note card"/>
+          <p:cNvSpPr/>
+          <p:nvPr/>
+        </p:nvSpPr>
+        <p:spPr>
+          <a:xfrm>
+            <a:off x="548640" y="5596128"/>
+            <a:ext cx="6172200" cy="585216"/>
+          </a:xfrm>
+          <a:prstGeom prst="roundRect">
+            <a:avLst>
+              <a:gd name="adj" fmla="val 8000"/>
+            </a:avLst>
+          </a:prstGeom>
+          <a:solidFill>
+            <a:srgbClr val="0B1A4A">
+              <a:alpha val="80000"/>
+            </a:srgbClr>
+          </a:solidFill>
+          <a:ln w="12700">
+            <a:solidFill>
+              <a:srgbClr val="1E5BFF"/>
+            </a:solidFill>
+          </a:ln>
+          <a:effectLst/>
+        </p:spPr>
+        <p:style>
+          <a:lnRef idx="1">
+            <a:schemeClr val="accent1"/>
+          </a:lnRef>
+          <a:fillRef idx="3">
+            <a:schemeClr val="accent1"/>
+          </a:fillRef>
+          <a:effectRef idx="2">
+            <a:schemeClr val="accent1"/>
+          </a:effectRef>
+          <a:fontRef idx="minor">
+            <a:schemeClr val="lt1"/>
+          </a:fontRef>
+        </p:style>
+        <p:txBody>
+          <a:bodyPr rtlCol="0" anchor="ctr"/>
+          <a:lstStyle/>
+          <a:p/>
+        </p:txBody>
+      </p:sp>
+      <p:sp>
+        <p:nvSpPr>
+          <p:cNvPr id="23" name="Demo note"/>
+          <p:cNvSpPr txBox="1"/>
+          <p:nvPr/>
+        </p:nvSpPr>
+        <p:spPr>
+          <a:xfrm>
+            <a:off x="658368" y="5641848"/>
+            <a:ext cx="5989320" cy="502920"/>
+          </a:xfrm>
+          <a:prstGeom prst="rect">
+            <a:avLst/>
+          </a:prstGeom>
+          <a:noFill/>
+        </p:spPr>
+        <p:txBody>
+          <a:bodyPr wrap="square" lIns="0" rIns="0" tIns="0" bIns="0" anchor="t">
+            <a:spAutoFit/>
+          </a:bodyPr>
+          <a:lstStyle/>
+          <a:p>
+            <a:pPr algn="l"/>
+            <a:r>
+              <a:rPr sz="1150" b="1" i="0">
+                <a:solidFill>
+                  <a:srgbClr val="4DA3FF"/>
+                </a:solidFill>
+                <a:latin typeface="Calibri"/>
+              </a:rPr>
+              <a:t>Note: </a:t>
+            </a:r>
+            <a:r>
+              <a:rPr sz="1150" b="1" i="0">
+                <a:solidFill>
+                  <a:srgbClr val="FFFFFF"/>
+                </a:solidFill>
+                <a:latin typeface="Calibri"/>
+              </a:rPr>
+              <a:t>A run on uploaded documents takes more time, so we built Demo mode. We recommend using Demo mode to see how ARENA works and the kind of results it gives.</a:t>
+            </a:r>
           </a:p>
         </p:txBody>
       </p:sp>

</xml_diff>